<commit_message>
data-eng 4-5 덱 5(w4d5s0 신설)·묶음
</commit_message>
<xml_diff>
--- a/data-eng/decks/w4d5s1.pptx
+++ b/data-eng/decks/w4d5s1.pptx
@@ -3100,7 +3100,7 @@
       <p:grpSpPr/>
       <p:sp>
         <p:nvSpPr>
-          <p:cNvPr id="2" name="Oval 1"/>
+          <p:cNvPr id="2" name="deckgen:decor"/>
           <p:cNvSpPr/>
           <p:nvPr/>
         </p:nvSpPr>
@@ -3130,7 +3130,7 @@
       </p:sp>
       <p:sp>
         <p:nvSpPr>
-          <p:cNvPr id="3" name="Oval 2"/>
+          <p:cNvPr id="3" name="deckgen:decor"/>
           <p:cNvSpPr/>
           <p:nvPr/>
         </p:nvSpPr>
@@ -3160,7 +3160,7 @@
       </p:sp>
       <p:sp>
         <p:nvSpPr>
-          <p:cNvPr id="4" name="Oval 3"/>
+          <p:cNvPr id="4" name="deckgen:decor"/>
           <p:cNvSpPr/>
           <p:nvPr/>
         </p:nvSpPr>
@@ -3190,7 +3190,7 @@
       </p:sp>
       <p:sp>
         <p:nvSpPr>
-          <p:cNvPr id="5" name="Rectangle 4"/>
+          <p:cNvPr id="5" name="deckgen:decor"/>
           <p:cNvSpPr/>
           <p:nvPr/>
         </p:nvSpPr>
@@ -3220,7 +3220,7 @@
       </p:sp>
       <p:sp>
         <p:nvSpPr>
-          <p:cNvPr id="6" name="Oval 5"/>
+          <p:cNvPr id="6" name="deckgen:decor"/>
           <p:cNvSpPr/>
           <p:nvPr/>
         </p:nvSpPr>
@@ -3250,7 +3250,7 @@
       </p:sp>
       <p:sp>
         <p:nvSpPr>
-          <p:cNvPr id="7" name="Oval 6"/>
+          <p:cNvPr id="7" name="deckgen:decor"/>
           <p:cNvSpPr/>
           <p:nvPr/>
         </p:nvSpPr>
@@ -3280,7 +3280,7 @@
       </p:sp>
       <p:sp>
         <p:nvSpPr>
-          <p:cNvPr id="8" name="Oval 7"/>
+          <p:cNvPr id="8" name="deckgen:decor"/>
           <p:cNvSpPr/>
           <p:nvPr/>
         </p:nvSpPr>
@@ -3310,7 +3310,7 @@
       </p:sp>
       <p:sp>
         <p:nvSpPr>
-          <p:cNvPr id="9" name="Oval 8"/>
+          <p:cNvPr id="9" name="deckgen:decor"/>
           <p:cNvSpPr/>
           <p:nvPr/>
         </p:nvSpPr>
@@ -3340,7 +3340,7 @@
       </p:sp>
       <p:sp>
         <p:nvSpPr>
-          <p:cNvPr id="10" name="Rectangle 9"/>
+          <p:cNvPr id="10" name="deckgen:decor"/>
           <p:cNvSpPr/>
           <p:nvPr/>
         </p:nvSpPr>
@@ -3600,7 +3600,7 @@
       <p:grpSpPr/>
       <p:sp>
         <p:nvSpPr>
-          <p:cNvPr id="2" name="Oval 1"/>
+          <p:cNvPr id="2" name="deckgen:decor"/>
           <p:cNvSpPr/>
           <p:nvPr/>
         </p:nvSpPr>
@@ -3630,7 +3630,7 @@
       </p:sp>
       <p:sp>
         <p:nvSpPr>
-          <p:cNvPr id="3" name="Oval 2"/>
+          <p:cNvPr id="3" name="deckgen:decor"/>
           <p:cNvSpPr/>
           <p:nvPr/>
         </p:nvSpPr>
@@ -3660,7 +3660,7 @@
       </p:sp>
       <p:sp>
         <p:nvSpPr>
-          <p:cNvPr id="4" name="Oval 3"/>
+          <p:cNvPr id="4" name="deckgen:decor"/>
           <p:cNvSpPr/>
           <p:nvPr/>
         </p:nvSpPr>
@@ -4662,7 +4662,7 @@
       <p:grpSpPr/>
       <p:sp>
         <p:nvSpPr>
-          <p:cNvPr id="2" name="Oval 1"/>
+          <p:cNvPr id="2" name="deckgen:decor"/>
           <p:cNvSpPr/>
           <p:nvPr/>
         </p:nvSpPr>
@@ -4692,7 +4692,7 @@
       </p:sp>
       <p:sp>
         <p:nvSpPr>
-          <p:cNvPr id="3" name="Oval 2"/>
+          <p:cNvPr id="3" name="deckgen:decor"/>
           <p:cNvSpPr/>
           <p:nvPr/>
         </p:nvSpPr>
@@ -5469,7 +5469,7 @@
       <p:grpSpPr/>
       <p:sp>
         <p:nvSpPr>
-          <p:cNvPr id="2" name="Oval 1"/>
+          <p:cNvPr id="2" name="deckgen:decor"/>
           <p:cNvSpPr/>
           <p:nvPr/>
         </p:nvSpPr>
@@ -5499,7 +5499,7 @@
       </p:sp>
       <p:sp>
         <p:nvSpPr>
-          <p:cNvPr id="3" name="Oval 2"/>
+          <p:cNvPr id="3" name="deckgen:decor"/>
           <p:cNvSpPr/>
           <p:nvPr/>
         </p:nvSpPr>
@@ -5529,7 +5529,7 @@
       </p:sp>
       <p:sp>
         <p:nvSpPr>
-          <p:cNvPr id="4" name="Oval 3"/>
+          <p:cNvPr id="4" name="deckgen:decor"/>
           <p:cNvSpPr/>
           <p:nvPr/>
         </p:nvSpPr>
@@ -6460,7 +6460,7 @@
       <p:grpSpPr/>
       <p:sp>
         <p:nvSpPr>
-          <p:cNvPr id="2" name="Oval 1"/>
+          <p:cNvPr id="2" name="deckgen:decor"/>
           <p:cNvSpPr/>
           <p:nvPr/>
         </p:nvSpPr>
@@ -6490,7 +6490,7 @@
       </p:sp>
       <p:sp>
         <p:nvSpPr>
-          <p:cNvPr id="3" name="Oval 2"/>
+          <p:cNvPr id="3" name="deckgen:decor"/>
           <p:cNvSpPr/>
           <p:nvPr/>
         </p:nvSpPr>
@@ -6520,7 +6520,7 @@
       </p:sp>
       <p:sp>
         <p:nvSpPr>
-          <p:cNvPr id="4" name="Oval 3"/>
+          <p:cNvPr id="4" name="deckgen:decor"/>
           <p:cNvSpPr/>
           <p:nvPr/>
         </p:nvSpPr>
@@ -7848,7 +7848,7 @@
       <p:grpSpPr/>
       <p:sp>
         <p:nvSpPr>
-          <p:cNvPr id="2" name="Oval 1"/>
+          <p:cNvPr id="2" name="deckgen:decor"/>
           <p:cNvSpPr/>
           <p:nvPr/>
         </p:nvSpPr>
@@ -7878,7 +7878,7 @@
       </p:sp>
       <p:sp>
         <p:nvSpPr>
-          <p:cNvPr id="3" name="Oval 2"/>
+          <p:cNvPr id="3" name="deckgen:decor"/>
           <p:cNvSpPr/>
           <p:nvPr/>
         </p:nvSpPr>
@@ -7908,7 +7908,7 @@
       </p:sp>
       <p:sp>
         <p:nvSpPr>
-          <p:cNvPr id="4" name="Oval 3"/>
+          <p:cNvPr id="4" name="deckgen:decor"/>
           <p:cNvSpPr/>
           <p:nvPr/>
         </p:nvSpPr>
@@ -10005,7 +10005,7 @@
       <p:grpSpPr/>
       <p:sp>
         <p:nvSpPr>
-          <p:cNvPr id="2" name="Oval 1"/>
+          <p:cNvPr id="2" name="deckgen:decor"/>
           <p:cNvSpPr/>
           <p:nvPr/>
         </p:nvSpPr>
@@ -10035,7 +10035,7 @@
       </p:sp>
       <p:sp>
         <p:nvSpPr>
-          <p:cNvPr id="3" name="Oval 2"/>
+          <p:cNvPr id="3" name="deckgen:decor"/>
           <p:cNvSpPr/>
           <p:nvPr/>
         </p:nvSpPr>
@@ -10065,7 +10065,7 @@
       </p:sp>
       <p:sp>
         <p:nvSpPr>
-          <p:cNvPr id="4" name="Oval 3"/>
+          <p:cNvPr id="4" name="deckgen:decor"/>
           <p:cNvSpPr/>
           <p:nvPr/>
         </p:nvSpPr>
@@ -11032,7 +11032,7 @@
       <p:grpSpPr/>
       <p:sp>
         <p:nvSpPr>
-          <p:cNvPr id="2" name="Oval 1"/>
+          <p:cNvPr id="2" name="deckgen:decor"/>
           <p:cNvSpPr/>
           <p:nvPr/>
         </p:nvSpPr>
@@ -11062,7 +11062,7 @@
       </p:sp>
       <p:sp>
         <p:nvSpPr>
-          <p:cNvPr id="3" name="Oval 2"/>
+          <p:cNvPr id="3" name="deckgen:decor"/>
           <p:cNvSpPr/>
           <p:nvPr/>
         </p:nvSpPr>
@@ -11092,7 +11092,7 @@
       </p:sp>
       <p:sp>
         <p:nvSpPr>
-          <p:cNvPr id="4" name="Oval 3"/>
+          <p:cNvPr id="4" name="deckgen:decor"/>
           <p:cNvSpPr/>
           <p:nvPr/>
         </p:nvSpPr>
@@ -12093,7 +12093,7 @@
       <p:grpSpPr/>
       <p:sp>
         <p:nvSpPr>
-          <p:cNvPr id="2" name="Oval 1"/>
+          <p:cNvPr id="2" name="deckgen:decor"/>
           <p:cNvSpPr/>
           <p:nvPr/>
         </p:nvSpPr>
@@ -12123,7 +12123,7 @@
       </p:sp>
       <p:sp>
         <p:nvSpPr>
-          <p:cNvPr id="3" name="Oval 2"/>
+          <p:cNvPr id="3" name="deckgen:decor"/>
           <p:cNvSpPr/>
           <p:nvPr/>
         </p:nvSpPr>
@@ -12153,7 +12153,7 @@
       </p:sp>
       <p:sp>
         <p:nvSpPr>
-          <p:cNvPr id="4" name="Oval 3"/>
+          <p:cNvPr id="4" name="deckgen:decor"/>
           <p:cNvSpPr/>
           <p:nvPr/>
         </p:nvSpPr>
@@ -13804,7 +13804,7 @@
       <p:grpSpPr/>
       <p:sp>
         <p:nvSpPr>
-          <p:cNvPr id="2" name="Oval 1"/>
+          <p:cNvPr id="2" name="deckgen:decor"/>
           <p:cNvSpPr/>
           <p:nvPr/>
         </p:nvSpPr>
@@ -13834,7 +13834,7 @@
       </p:sp>
       <p:sp>
         <p:nvSpPr>
-          <p:cNvPr id="3" name="Oval 2"/>
+          <p:cNvPr id="3" name="deckgen:decor"/>
           <p:cNvSpPr/>
           <p:nvPr/>
         </p:nvSpPr>
@@ -13864,7 +13864,7 @@
       </p:sp>
       <p:sp>
         <p:nvSpPr>
-          <p:cNvPr id="4" name="Oval 3"/>
+          <p:cNvPr id="4" name="deckgen:decor"/>
           <p:cNvSpPr/>
           <p:nvPr/>
         </p:nvSpPr>
@@ -14995,7 +14995,7 @@
       <p:grpSpPr/>
       <p:sp>
         <p:nvSpPr>
-          <p:cNvPr id="2" name="Oval 1"/>
+          <p:cNvPr id="2" name="deckgen:decor"/>
           <p:cNvSpPr/>
           <p:nvPr/>
         </p:nvSpPr>
@@ -15025,7 +15025,7 @@
       </p:sp>
       <p:sp>
         <p:nvSpPr>
-          <p:cNvPr id="3" name="Oval 2"/>
+          <p:cNvPr id="3" name="deckgen:decor"/>
           <p:cNvSpPr/>
           <p:nvPr/>
         </p:nvSpPr>
@@ -15055,7 +15055,7 @@
       </p:sp>
       <p:sp>
         <p:nvSpPr>
-          <p:cNvPr id="4" name="Oval 3"/>
+          <p:cNvPr id="4" name="deckgen:decor"/>
           <p:cNvSpPr/>
           <p:nvPr/>
         </p:nvSpPr>

</xml_diff>